<commit_message>
feat: add TCA monitoring metrics and report generation
- Introduced monitoring metrics constants in `monitoring-metrics.ts` for TCA, aligning with backend whitelists.
- Created a CLI tool in `generate_tca_report.py` for generating self-contained HTML reports of TCA visualizations, supporting various time ranges and metric filters.
- Developed an HTML report renderer in `tca_report_html.py`, featuring inline CSS and server-generated SVG charts, ensuring no external dependencies.
</commit_message>
<xml_diff>
--- a/algorithmic transaction cost analysis.pptx
+++ b/algorithmic transaction cost analysis.pptx
@@ -199,7 +199,7 @@
           <a:p>
             <a:fld id="{25B4C2CA-7E2E-4182-891D-BFF1883827E1}" type="datetimeFigureOut">
               <a:rPr lang="en-HK" smtClean="0"/>
-              <a:t>16/7/2026</a:t>
+              <a:t>4/8/2026</a:t>
             </a:fld>
             <a:endParaRPr lang="en-HK"/>
           </a:p>
@@ -509,7 +509,7 @@
           <a:p>
             <a:fld id="{5109407B-7E3E-4641-99EB-C14D4B21DBB2}" type="datetime1">
               <a:rPr lang="en-HK" smtClean="0"/>
-              <a:t>16/7/2026</a:t>
+              <a:t>4/8/2026</a:t>
             </a:fld>
             <a:endParaRPr lang="en-HK"/>
           </a:p>
@@ -906,7 +906,7 @@
           <a:p>
             <a:fld id="{A2889A43-4008-410B-9A04-BFB7E873791C}" type="datetime1">
               <a:rPr lang="en-HK" smtClean="0"/>
-              <a:t>16/7/2026</a:t>
+              <a:t>4/8/2026</a:t>
             </a:fld>
             <a:endParaRPr lang="en-HK"/>
           </a:p>
@@ -1132,7 +1132,7 @@
           <a:p>
             <a:fld id="{19254B67-67B9-4A26-9A5D-5946C6C5E0D0}" type="datetime1">
               <a:rPr lang="en-HK" smtClean="0"/>
-              <a:t>16/7/2026</a:t>
+              <a:t>4/8/2026</a:t>
             </a:fld>
             <a:endParaRPr lang="en-HK"/>
           </a:p>
@@ -1243,7 +1243,7 @@
           <a:p>
             <a:fld id="{9875C19C-A999-4750-9842-803FD77029DF}" type="datetime1">
               <a:rPr lang="en-HK" smtClean="0"/>
-              <a:t>16/7/2026</a:t>
+              <a:t>4/8/2026</a:t>
             </a:fld>
             <a:endParaRPr lang="en-HK"/>
           </a:p>
@@ -2437,7 +2437,7 @@
           <a:p>
             <a:fld id="{DDF0CDEB-0288-4C73-BFDF-5CD0B70BF0BB}" type="datetime1">
               <a:rPr lang="en-HK" smtClean="0"/>
-              <a:t>16/7/2026</a:t>
+              <a:t>4/8/2026</a:t>
             </a:fld>
             <a:endParaRPr lang="en-HK"/>
           </a:p>
@@ -2757,7 +2757,7 @@
           <a:p>
             <a:fld id="{307FBD4E-27AF-4147-8FC3-FBDAAFF80132}" type="datetime1">
               <a:rPr lang="en-HK" smtClean="0"/>
-              <a:t>16/7/2026</a:t>
+              <a:t>4/8/2026</a:t>
             </a:fld>
             <a:endParaRPr lang="en-HK"/>
           </a:p>
@@ -2949,7 +2949,7 @@
           <a:p>
             <a:fld id="{3CFA4097-4805-4569-A871-AD2812221AFF}" type="datetime1">
               <a:rPr lang="en-HK" smtClean="0"/>
-              <a:t>16/7/2026</a:t>
+              <a:t>4/8/2026</a:t>
             </a:fld>
             <a:endParaRPr lang="en-HK"/>
           </a:p>
@@ -3458,7 +3458,7 @@
           <a:p>
             <a:fld id="{CD1C043D-96B4-44E3-BFF6-F720BD2C6053}" type="datetime1">
               <a:rPr lang="en-HK" smtClean="0"/>
-              <a:t>16/7/2026</a:t>
+              <a:t>4/8/2026</a:t>
             </a:fld>
             <a:endParaRPr lang="en-HK"/>
           </a:p>
@@ -3601,7 +3601,7 @@
           <a:p>
             <a:fld id="{341BD68D-AF8D-4952-92DF-8AA70D387137}" type="datetime1">
               <a:rPr lang="en-HK" smtClean="0"/>
-              <a:t>16/7/2026</a:t>
+              <a:t>4/8/2026</a:t>
             </a:fld>
             <a:endParaRPr lang="en-HK"/>
           </a:p>
@@ -3744,7 +3744,7 @@
           <a:p>
             <a:fld id="{5585CC6C-980F-427F-9417-447E671D62C3}" type="datetime1">
               <a:rPr lang="en-HK" smtClean="0"/>
-              <a:t>16/7/2026</a:t>
+              <a:t>4/8/2026</a:t>
             </a:fld>
             <a:endParaRPr lang="en-HK"/>
           </a:p>
@@ -4037,7 +4037,7 @@
           <a:p>
             <a:fld id="{21CD99C7-11D8-4E6B-A134-9B2BA7F86818}" type="datetime1">
               <a:rPr lang="en-HK" smtClean="0"/>
-              <a:t>16/7/2026</a:t>
+              <a:t>4/8/2026</a:t>
             </a:fld>
             <a:endParaRPr lang="en-HK"/>
           </a:p>
@@ -4310,7 +4310,7 @@
           <a:p>
             <a:fld id="{7C44BE0D-B4E8-4AD6-8FB1-30946B68E369}" type="datetime1">
               <a:rPr lang="en-HK" smtClean="0"/>
-              <a:t>16/7/2026</a:t>
+              <a:t>4/8/2026</a:t>
             </a:fld>
             <a:endParaRPr lang="en-HK"/>
           </a:p>
@@ -5164,7 +5164,7 @@
             </a:r>
             <a:r>
               <a:rPr lang="en-US" altLang="zh-CN" dirty="0"/>
-              <a:t>August</a:t>
+              <a:t>September</a:t>
             </a:r>
             <a:endParaRPr lang="en-HK" dirty="0"/>
           </a:p>
@@ -5261,7 +5261,34 @@
           <a:bodyPr/>
           <a:lstStyle/>
           <a:p>
-            <a:endParaRPr lang="en-HK" dirty="0"/>
+            <a:r>
+              <a:rPr lang="en-HK" dirty="0"/>
+              <a:t>Implement shortfall</a:t>
+            </a:r>
+          </a:p>
+          <a:p>
+            <a:r>
+              <a:rPr lang="en-HK" dirty="0"/>
+              <a:t>Benchmark</a:t>
+            </a:r>
+          </a:p>
+          <a:p>
+            <a:r>
+              <a:rPr lang="en-HK" dirty="0"/>
+              <a:t>Evaluating performance</a:t>
+            </a:r>
+          </a:p>
+          <a:p>
+            <a:r>
+              <a:rPr lang="en-HK" dirty="0"/>
+              <a:t>Comparing algorithms</a:t>
+            </a:r>
+          </a:p>
+          <a:p>
+            <a:r>
+              <a:rPr lang="en-HK" dirty="0"/>
+              <a:t>Appendix</a:t>
+            </a:r>
           </a:p>
         </p:txBody>
       </p:sp>

</xml_diff>